<commit_message>
Fix text alignment and colors in presentation cards
</commit_message>
<xml_diff>
--- a/IT-Monitoring_Praesentation.pptx
+++ b/IT-Monitoring_Praesentation.pptx
@@ -4111,7 +4111,6 @@
             <a:spAutoFit/>
           </a:bodyPr>
           <a:lstStyle/>
-          <a:p/>
           <a:p>
             <a:pPr>
               <a:defRPr sz="6400" b="1">
@@ -4147,7 +4146,6 @@
             <a:spAutoFit/>
           </a:bodyPr>
           <a:lstStyle/>
-          <a:p/>
           <a:p>
             <a:pPr>
               <a:defRPr sz="3200">
@@ -4228,7 +4226,6 @@
             <a:spAutoFit/>
           </a:bodyPr>
           <a:lstStyle/>
-          <a:p/>
           <a:p>
             <a:pPr algn="ctr">
               <a:defRPr sz="2200">
@@ -4339,7 +4336,6 @@
             <a:spAutoFit/>
           </a:bodyPr>
           <a:lstStyle/>
-          <a:p/>
           <a:p>
             <a:pPr>
               <a:defRPr sz="4400" b="1">
@@ -4420,7 +4416,6 @@
             <a:spAutoFit/>
           </a:bodyPr>
           <a:lstStyle/>
-          <a:p/>
           <a:p>
             <a:pPr>
               <a:defRPr sz="3200" b="1">
@@ -4561,7 +4556,6 @@
             <a:spAutoFit/>
           </a:bodyPr>
           <a:lstStyle/>
-          <a:p/>
           <a:p>
             <a:pPr>
               <a:defRPr sz="3200" b="1">
@@ -4728,7 +4722,6 @@
             <a:spAutoFit/>
           </a:bodyPr>
           <a:lstStyle/>
-          <a:p/>
           <a:p>
             <a:pPr>
               <a:defRPr sz="4400" b="1">
@@ -4764,7 +4757,6 @@
             <a:spAutoFit/>
           </a:bodyPr>
           <a:lstStyle/>
-          <a:p/>
           <a:p>
             <a:pPr>
               <a:defRPr sz="2800">
@@ -4845,7 +4837,6 @@
             <a:spAutoFit/>
           </a:bodyPr>
           <a:lstStyle/>
-          <a:p/>
           <a:p>
             <a:pPr algn="ctr">
               <a:defRPr sz="3600" b="1">
@@ -4941,7 +4932,6 @@
             <a:spAutoFit/>
           </a:bodyPr>
           <a:lstStyle/>
-          <a:p/>
           <a:p>
             <a:pPr algn="ctr">
               <a:defRPr sz="3600" b="1">
@@ -5037,7 +5027,6 @@
             <a:spAutoFit/>
           </a:bodyPr>
           <a:lstStyle/>
-          <a:p/>
           <a:p>
             <a:pPr algn="ctr">
               <a:defRPr sz="3600" b="1">
@@ -5088,7 +5077,6 @@
             <a:spAutoFit/>
           </a:bodyPr>
           <a:lstStyle/>
-          <a:p/>
           <a:p>
             <a:pPr>
               <a:defRPr sz="2400" b="1">
@@ -5195,7 +5183,6 @@
             <a:spAutoFit/>
           </a:bodyPr>
           <a:lstStyle/>
-          <a:p/>
           <a:p>
             <a:pPr>
               <a:defRPr sz="4400" b="1">
@@ -5276,7 +5263,6 @@
             <a:spAutoFit/>
           </a:bodyPr>
           <a:lstStyle/>
-          <a:p/>
           <a:p>
             <a:pPr algn="ctr">
               <a:defRPr sz="2800" b="1">
@@ -5376,7 +5362,6 @@
             <a:spAutoFit/>
           </a:bodyPr>
           <a:lstStyle/>
-          <a:p/>
           <a:p>
             <a:pPr algn="ctr">
               <a:defRPr sz="2800" b="1">
@@ -5476,7 +5461,6 @@
             <a:spAutoFit/>
           </a:bodyPr>
           <a:lstStyle/>
-          <a:p/>
           <a:p>
             <a:pPr algn="ctr">
               <a:defRPr sz="2800" b="1">
@@ -5621,7 +5605,6 @@
             <a:spAutoFit/>
           </a:bodyPr>
           <a:lstStyle/>
-          <a:p/>
           <a:p>
             <a:pPr>
               <a:spcAft>
@@ -5743,7 +5726,6 @@
             <a:spAutoFit/>
           </a:bodyPr>
           <a:lstStyle/>
-          <a:p/>
           <a:p>
             <a:pPr>
               <a:defRPr sz="4400" b="1">
@@ -5824,7 +5806,6 @@
             <a:spAutoFit/>
           </a:bodyPr>
           <a:lstStyle/>
-          <a:p/>
           <a:p>
             <a:pPr>
               <a:defRPr sz="3200" b="1">
@@ -6018,7 +5999,6 @@
             <a:spAutoFit/>
           </a:bodyPr>
           <a:lstStyle/>
-          <a:p/>
           <a:p>
             <a:pPr>
               <a:defRPr sz="4400" b="1">
@@ -6054,7 +6034,6 @@
             <a:spAutoFit/>
           </a:bodyPr>
           <a:lstStyle/>
-          <a:p/>
           <a:p>
             <a:pPr>
               <a:defRPr sz="2600">
@@ -6188,8 +6167,6 @@
                 </a:solidFill>
               </a:defRPr>
             </a:pPr>
-          </a:p>
-          <a:p>
             <a:r>
               <a:t>Apache-Ausfall</a:t>
             </a:r>
@@ -6219,14 +6196,12 @@
           <a:lstStyle/>
           <a:p>
             <a:pPr>
-              <a:defRPr sz="2200">
+              <a:defRPr sz="2400">
                 <a:solidFill>
                   <a:srgbClr val="94A3B8"/>
                 </a:solidFill>
               </a:defRPr>
             </a:pPr>
-          </a:p>
-          <a:p>
             <a:r>
               <a:t>Service gestoppt</a:t>
             </a:r>
@@ -6256,14 +6231,12 @@
           <a:lstStyle/>
           <a:p>
             <a:pPr>
-              <a:defRPr sz="2400" b="1">
+              <a:defRPr sz="2600" b="1">
                 <a:solidFill>
                   <a:srgbClr val="10B981"/>
                 </a:solidFill>
               </a:defRPr>
             </a:pPr>
-          </a:p>
-          <a:p>
             <a:r>
               <a:t>HTTP_Apache → CRIT</a:t>
             </a:r>
@@ -6389,8 +6362,6 @@
                 </a:solidFill>
               </a:defRPr>
             </a:pPr>
-          </a:p>
-          <a:p>
             <a:r>
               <a:t>CPU-Volllast</a:t>
             </a:r>
@@ -6420,14 +6391,12 @@
           <a:lstStyle/>
           <a:p>
             <a:pPr>
-              <a:defRPr sz="2200">
+              <a:defRPr sz="2400">
                 <a:solidFill>
                   <a:srgbClr val="94A3B8"/>
                 </a:solidFill>
               </a:defRPr>
             </a:pPr>
-          </a:p>
-          <a:p>
             <a:r>
               <a:t>Stress-Test (stress --cpu)</a:t>
             </a:r>
@@ -6457,14 +6426,12 @@
           <a:lstStyle/>
           <a:p>
             <a:pPr>
-              <a:defRPr sz="2400" b="1">
+              <a:defRPr sz="2600" b="1">
                 <a:solidFill>
                   <a:srgbClr val="10B981"/>
                 </a:solidFill>
               </a:defRPr>
             </a:pPr>
-          </a:p>
-          <a:p>
             <a:r>
               <a:t>CPU utilization → WARN/CRIT</a:t>
             </a:r>
@@ -6590,8 +6557,6 @@
                 </a:solidFill>
               </a:defRPr>
             </a:pPr>
-          </a:p>
-          <a:p>
             <a:r>
               <a:t>Festplatte voll</a:t>
             </a:r>
@@ -6621,14 +6586,12 @@
           <a:lstStyle/>
           <a:p>
             <a:pPr>
-              <a:defRPr sz="2200">
+              <a:defRPr sz="2400">
                 <a:solidFill>
                   <a:srgbClr val="94A3B8"/>
                 </a:solidFill>
               </a:defRPr>
             </a:pPr>
-          </a:p>
-          <a:p>
             <a:r>
               <a:t>dd command für 20GB</a:t>
             </a:r>
@@ -6658,14 +6621,12 @@
           <a:lstStyle/>
           <a:p>
             <a:pPr>
-              <a:defRPr sz="2400" b="1">
+              <a:defRPr sz="2600" b="1">
                 <a:solidFill>
                   <a:srgbClr val="10B981"/>
                 </a:solidFill>
               </a:defRPr>
             </a:pPr>
-          </a:p>
-          <a:p>
             <a:r>
               <a:t>Filesystem / → CRIT</a:t>
             </a:r>
@@ -6791,8 +6752,6 @@
                 </a:solidFill>
               </a:defRPr>
             </a:pPr>
-          </a:p>
-          <a:p>
             <a:r>
               <a:t>Host-Ausfall</a:t>
             </a:r>
@@ -6822,14 +6781,12 @@
           <a:lstStyle/>
           <a:p>
             <a:pPr>
-              <a:defRPr sz="2200">
+              <a:defRPr sz="2400">
                 <a:solidFill>
                   <a:srgbClr val="94A3B8"/>
                 </a:solidFill>
               </a:defRPr>
             </a:pPr>
-          </a:p>
-          <a:p>
             <a:r>
               <a:t>VM ausgeschaltet</a:t>
             </a:r>
@@ -6859,14 +6816,12 @@
           <a:lstStyle/>
           <a:p>
             <a:pPr>
-              <a:defRPr sz="2400" b="1">
+              <a:defRPr sz="2600" b="1">
                 <a:solidFill>
                   <a:srgbClr val="10B981"/>
                 </a:solidFill>
               </a:defRPr>
             </a:pPr>
-          </a:p>
-          <a:p>
             <a:r>
               <a:t>Host DOWN (Ping Fail)</a:t>
             </a:r>
@@ -6965,7 +6920,6 @@
             <a:spAutoFit/>
           </a:bodyPr>
           <a:lstStyle/>
-          <a:p/>
           <a:p>
             <a:pPr>
               <a:defRPr sz="4400" b="1">
@@ -7046,7 +7000,6 @@
             <a:spAutoFit/>
           </a:bodyPr>
           <a:lstStyle/>
-          <a:p/>
           <a:p>
             <a:pPr>
               <a:defRPr sz="3200" b="1">

</xml_diff>